<commit_message>
Added some cosmetic changes
</commit_message>
<xml_diff>
--- a/Документы/1596_Шорсткин_Козлов_Приложение_Для_ведения_автомобильного_журнала.pptx
+++ b/Документы/1596_Шорсткин_Козлов_Приложение_Для_ведения_автомобильного_журнала.pptx
@@ -49494,49 +49494,6 @@
               </a:rPr>
               <a:t>Козлов Никита Алексеевич</a:t>
             </a:r>
-            <a:endParaRPr lang="ru-RU" altLang="x-none" sz="2000" baseline="0" dirty="0" err="1">
-              <a:latin typeface="Arial" panose="020B0604020202020204" pitchFamily="34" charset="0"/>
-              <a:cs typeface="Calibri" panose="020F0502020204030204" charset="0"/>
-            </a:endParaRPr>
-          </a:p>
-          <a:p>
-            <a:pPr defTabSz="914400" hangingPunct="1">
-              <a:lnSpc>
-                <a:spcPct val="100000"/>
-              </a:lnSpc>
-              <a:buNone/>
-              <a:tabLst>
-                <a:tab pos="0" algn="l"/>
-                <a:tab pos="914400" algn="l"/>
-                <a:tab pos="1828800" algn="l"/>
-                <a:tab pos="2743200" algn="l"/>
-              </a:tabLst>
-            </a:pPr>
-            <a:r>
-              <a:rPr lang="ru-RU" altLang="x-none" sz="2000" baseline="0" dirty="0" err="1">
-                <a:latin typeface="Arial" panose="020B0604020202020204" pitchFamily="34" charset="0"/>
-                <a:cs typeface="Calibri" panose="020F0502020204030204" charset="0"/>
-              </a:rPr>
-              <a:t>Селютин Егор Максимович</a:t>
-            </a:r>
-            <a:endParaRPr lang="ru-RU" altLang="x-none" sz="2000" baseline="0" dirty="0" err="1">
-              <a:latin typeface="Arial" panose="020B0604020202020204" pitchFamily="34" charset="0"/>
-              <a:cs typeface="Calibri" panose="020F0502020204030204" charset="0"/>
-            </a:endParaRPr>
-          </a:p>
-          <a:p>
-            <a:pPr defTabSz="914400" hangingPunct="1">
-              <a:lnSpc>
-                <a:spcPct val="100000"/>
-              </a:lnSpc>
-              <a:buNone/>
-              <a:tabLst>
-                <a:tab pos="0" algn="l"/>
-                <a:tab pos="914400" algn="l"/>
-                <a:tab pos="1828800" algn="l"/>
-                <a:tab pos="2743200" algn="l"/>
-              </a:tabLst>
-            </a:pPr>
             <a:endParaRPr lang="ru-RU" altLang="x-none" sz="2000" baseline="0" dirty="0" err="1">
               <a:latin typeface="Arial" panose="020B0604020202020204" pitchFamily="34" charset="0"/>
               <a:ea typeface="Calibri" panose="020F0502020204030204" charset="0"/>

</xml_diff>